<commit_message>
docs(slides): Agentic AI + 온디바이스 LLM 통합 도식 추가
- 두 기술을 'A + B -> 결론' 구조로 합친 도식 신규 (png / drawio)
  Agentic AI(스스로 실행) + 온디바이스 LLM(기기 내 추론)
  -> 단말 내 자율 협상, 데이터는 밖으로 나가지 않음
- 기술환경-도식.pptx 에 4번째 슬라이드로 추가 (네이티브 도형)
- 발표대본 정본/단축본의 슬라이드 수정 사항에 사용법 반영

Co-Authored-By: Claude Opus 5 <noreply@anthropic.com>
Claude-Session: https://claude.ai/code/session_014eVMKd7sBnh1FX273pxzYt
</commit_message>
<xml_diff>
--- a/docs/slides/images/기술환경-도식.pptx
+++ b/docs/slides/images/기술환경-도식.pptx
@@ -8,9 +8,10 @@
     <p:sldId id="256" r:id="rId2"/>
     <p:sldId id="257" r:id="rId3"/>
     <p:sldId id="258" r:id="rId4"/>
+    <p:sldId id="259" r:id="rId5"/>
   </p:sldIdLst>
   <p:notesMasterIdLst>
-    <p:notesMasterId r:id="rId5"/>
+    <p:notesMasterId r:id="rId6"/>
   </p:notesMasterIdLst>
   <p:sldSz cx="12192000" cy="6858000"/>
   <p:notesSz cx="6858000" cy="12192000"/>
@@ -722,6 +723,94 @@
 </p:notes>
 </file>
 
+<file path=ppt/notesSlides/notesSlide4.xml><?xml version="1.0" encoding="utf-8"?>
+<p:notes xmlns:a="http://schemas.openxmlformats.org/drawingml/2006/main" xmlns:r="http://schemas.openxmlformats.org/officeDocument/2006/relationships" xmlns:p="http://schemas.openxmlformats.org/presentationml/2006/main">
+  <p:cSld>
+    <p:spTree>
+      <p:nvGrpSpPr>
+        <p:cNvPr id="1" name=""/>
+        <p:cNvGrpSpPr/>
+        <p:nvPr/>
+      </p:nvGrpSpPr>
+      <p:grpSpPr>
+        <a:xfrm>
+          <a:off x="0" y="0"/>
+          <a:ext cx="0" cy="0"/>
+          <a:chOff x="0" y="0"/>
+          <a:chExt cx="0" cy="0"/>
+        </a:xfrm>
+      </p:grpSpPr>
+      <p:sp>
+        <p:nvSpPr>
+          <p:cNvPr id="2" name="Slide Image Placeholder 1"/>
+          <p:cNvSpPr>
+            <a:spLocks noGrp="1" noRot="1" noChangeAspect="1"/>
+          </p:cNvSpPr>
+          <p:nvPr>
+            <p:ph type="sldImg"/>
+          </p:nvPr>
+        </p:nvSpPr>
+        <p:spPr/>
+      </p:sp>
+      <p:sp>
+        <p:nvSpPr>
+          <p:cNvPr id="3" name="Notes Placeholder 2"/>
+          <p:cNvSpPr>
+            <a:spLocks noGrp="1"/>
+          </p:cNvSpPr>
+          <p:nvPr>
+            <p:ph type="body" idx="1"/>
+          </p:nvPr>
+        </p:nvSpPr>
+        <p:spPr/>
+        <p:txBody>
+          <a:bodyPr/>
+          <a:lstStyle/>
+          <a:p>
+            <a:r>
+              <a:rPr lang="en-US" dirty="0"/>
+              <a:t/>
+            </a:r>
+            <a:endParaRPr lang="en-US" dirty="0"/>
+          </a:p>
+        </p:txBody>
+      </p:sp>
+      <p:sp>
+        <p:nvSpPr>
+          <p:cNvPr id="4" name="Slide Number Placeholder 3"/>
+          <p:cNvSpPr>
+            <a:spLocks noGrp="1"/>
+          </p:cNvSpPr>
+          <p:nvPr>
+            <p:ph type="sldNum" sz="quarter" idx="10"/>
+          </p:nvPr>
+        </p:nvSpPr>
+        <p:spPr/>
+        <p:txBody>
+          <a:bodyPr/>
+          <a:lstStyle/>
+          <a:p>
+            <a:fld id="{F7021451-1387-4CA6-816F-3879F97B5CBC}" type="slidenum">
+              <a:rPr lang="en-US"/>
+              <a:t>4</a:t>
+            </a:fld>
+            <a:endParaRPr lang="en-US"/>
+          </a:p>
+        </p:txBody>
+      </p:sp>
+    </p:spTree>
+    <p:extLst>
+      <p:ext uri="{BB962C8B-B14F-4D97-AF65-F5344CB8AC3E}">
+        <p14:creationId xmlns:p14="http://schemas.microsoft.com/office/powerpoint/2010/main" val="1024086991"/>
+      </p:ext>
+    </p:extLst>
+  </p:cSld>
+  <p:clrMapOvr>
+    <a:masterClrMapping/>
+  </p:clrMapOvr>
+</p:notes>
+</file>
+
 <file path=ppt/slideLayouts/slideLayout1.xml><?xml version="1.0" encoding="utf-8"?>
 <p:sldLayout xmlns:a="http://schemas.openxmlformats.org/drawingml/2006/main" xmlns:r="http://schemas.openxmlformats.org/officeDocument/2006/relationships" xmlns:p="http://schemas.openxmlformats.org/presentationml/2006/main" preserve="1">
   <p:cSld name="DEFAULT">
@@ -2622,6 +2711,845 @@
               <a:t>외부 서버</a:t>
             </a:r>
             <a:endParaRPr lang="en-US" sz="2490" dirty="0"/>
+          </a:p>
+        </p:txBody>
+      </p:sp>
+    </p:spTree>
+  </p:cSld>
+  <p:clrMapOvr>
+    <a:masterClrMapping/>
+  </p:clrMapOvr>
+</p:sld>
+</file>
+
+<file path=ppt/slides/slide4.xml><?xml version="1.0" encoding="utf-8"?>
+<p:sld xmlns:a="http://schemas.openxmlformats.org/drawingml/2006/main" xmlns:r="http://schemas.openxmlformats.org/officeDocument/2006/relationships" xmlns:p="http://schemas.openxmlformats.org/presentationml/2006/main">
+  <p:cSld name="Slide 4">
+    <p:bg>
+      <p:bgPr>
+        <a:solidFill>
+          <a:srgbClr val="FFFFFF"/>
+        </a:solidFill>
+      </p:bgPr>
+    </p:bg>
+    <p:spTree>
+      <p:nvGrpSpPr>
+        <p:cNvPr id="1" name=""/>
+        <p:cNvGrpSpPr/>
+        <p:nvPr/>
+      </p:nvGrpSpPr>
+      <p:grpSpPr>
+        <a:xfrm>
+          <a:off x="0" y="0"/>
+          <a:ext cx="0" cy="0"/>
+          <a:chOff x="0" y="0"/>
+          <a:chExt cx="0" cy="0"/>
+        </a:xfrm>
+      </p:grpSpPr>
+      <p:sp>
+        <p:nvSpPr>
+          <p:cNvPr id="2" name="Text 0"/>
+          <p:cNvSpPr/>
+          <p:nvPr/>
+        </p:nvSpPr>
+        <p:spPr>
+          <a:xfrm>
+            <a:off x="1066648" y="1658080"/>
+            <a:ext cx="10058400" cy="385215"/>
+          </a:xfrm>
+          <a:prstGeom prst="rect">
+            <a:avLst/>
+          </a:prstGeom>
+          <a:noFill/>
+          <a:ln/>
+        </p:spPr>
+        <p:txBody>
+          <a:bodyPr wrap="square" lIns="0" tIns="0" rIns="0" bIns="0" rtlCol="0" anchor="ctr"/>
+          <a:lstStyle/>
+          <a:p>
+            <a:pPr algn="ctr" indent="0" marL="0">
+              <a:buNone/>
+            </a:pPr>
+            <a:r>
+              <a:rPr lang="en-US" sz="2700" b="1" dirty="0">
+                <a:solidFill>
+                  <a:srgbClr val="2E3B4E"/>
+                </a:solidFill>
+                <a:latin typeface="맑은 고딕" pitchFamily="34" charset="0"/>
+                <a:ea typeface="맑은 고딕" pitchFamily="34" charset="-122"/>
+                <a:cs typeface="맑은 고딕" pitchFamily="34" charset="-120"/>
+              </a:rPr>
+              <a:t>Agentic AI + 온디바이스 LLM — 단말 안에서 자율 협상</a:t>
+            </a:r>
+            <a:endParaRPr lang="en-US" sz="2700" dirty="0"/>
+          </a:p>
+        </p:txBody>
+      </p:sp>
+      <p:sp>
+        <p:nvSpPr>
+          <p:cNvPr id="3" name="Shape 1"/>
+          <p:cNvSpPr/>
+          <p:nvPr/>
+        </p:nvSpPr>
+        <p:spPr>
+          <a:xfrm>
+            <a:off x="1387660" y="2407109"/>
+            <a:ext cx="2461098" cy="2193587"/>
+          </a:xfrm>
+          <a:prstGeom prst="roundRect">
+            <a:avLst>
+              <a:gd name="adj" fmla="val 2501"/>
+            </a:avLst>
+          </a:prstGeom>
+          <a:solidFill>
+            <a:srgbClr val="F4F6F9"/>
+          </a:solidFill>
+          <a:ln w="13970">
+            <a:solidFill>
+              <a:srgbClr val="D6DBE1"/>
+            </a:solidFill>
+            <a:prstDash val="solid"/>
+          </a:ln>
+        </p:spPr>
+      </p:sp>
+      <p:sp>
+        <p:nvSpPr>
+          <p:cNvPr id="4" name="Shape 2"/>
+          <p:cNvSpPr/>
+          <p:nvPr/>
+        </p:nvSpPr>
+        <p:spPr>
+          <a:xfrm>
+            <a:off x="2168791" y="2663920"/>
+            <a:ext cx="898836" cy="898836"/>
+          </a:xfrm>
+          <a:prstGeom prst="gear9">
+            <a:avLst/>
+          </a:prstGeom>
+          <a:solidFill>
+            <a:srgbClr val="3A6096"/>
+          </a:solidFill>
+          <a:ln w="12700">
+            <a:solidFill>
+              <a:srgbClr val="3A6096"/>
+            </a:solidFill>
+            <a:prstDash val="solid"/>
+          </a:ln>
+        </p:spPr>
+      </p:sp>
+      <p:sp>
+        <p:nvSpPr>
+          <p:cNvPr id="5" name="Shape 3"/>
+          <p:cNvSpPr/>
+          <p:nvPr/>
+        </p:nvSpPr>
+        <p:spPr>
+          <a:xfrm>
+            <a:off x="2479104" y="2974232"/>
+            <a:ext cx="278211" cy="278211"/>
+          </a:xfrm>
+          <a:prstGeom prst="ellipse">
+            <a:avLst/>
+          </a:prstGeom>
+          <a:solidFill>
+            <a:srgbClr val="F4F6F9"/>
+          </a:solidFill>
+          <a:ln w="12700">
+            <a:solidFill>
+              <a:srgbClr val="F4F6F9"/>
+            </a:solidFill>
+            <a:prstDash val="solid"/>
+          </a:ln>
+        </p:spPr>
+      </p:sp>
+      <p:sp>
+        <p:nvSpPr>
+          <p:cNvPr id="6" name="Text 4"/>
+          <p:cNvSpPr/>
+          <p:nvPr/>
+        </p:nvSpPr>
+        <p:spPr>
+          <a:xfrm>
+            <a:off x="1387660" y="3776764"/>
+            <a:ext cx="2461098" cy="342414"/>
+          </a:xfrm>
+          <a:prstGeom prst="rect">
+            <a:avLst/>
+          </a:prstGeom>
+          <a:noFill/>
+          <a:ln/>
+        </p:spPr>
+        <p:txBody>
+          <a:bodyPr wrap="square" lIns="0" tIns="0" rIns="0" bIns="0" rtlCol="0" anchor="ctr"/>
+          <a:lstStyle/>
+          <a:p>
+            <a:pPr algn="ctr" indent="0" marL="0">
+              <a:buNone/>
+            </a:pPr>
+            <a:r>
+              <a:rPr lang="en-US" sz="2190" b="1" dirty="0">
+                <a:solidFill>
+                  <a:srgbClr val="2E3B4E"/>
+                </a:solidFill>
+                <a:latin typeface="맑은 고딕" pitchFamily="34" charset="0"/>
+                <a:ea typeface="맑은 고딕" pitchFamily="34" charset="-122"/>
+                <a:cs typeface="맑은 고딕" pitchFamily="34" charset="-120"/>
+              </a:rPr>
+              <a:t>Agentic AI</a:t>
+            </a:r>
+            <a:endParaRPr lang="en-US" sz="2190" dirty="0"/>
+          </a:p>
+        </p:txBody>
+      </p:sp>
+      <p:sp>
+        <p:nvSpPr>
+          <p:cNvPr id="7" name="Text 5"/>
+          <p:cNvSpPr/>
+          <p:nvPr/>
+        </p:nvSpPr>
+        <p:spPr>
+          <a:xfrm>
+            <a:off x="1387660" y="4129878"/>
+            <a:ext cx="2461098" cy="299612"/>
+          </a:xfrm>
+          <a:prstGeom prst="rect">
+            <a:avLst/>
+          </a:prstGeom>
+          <a:noFill/>
+          <a:ln/>
+        </p:spPr>
+        <p:txBody>
+          <a:bodyPr wrap="square" lIns="0" tIns="0" rIns="0" bIns="0" rtlCol="0" anchor="ctr"/>
+          <a:lstStyle/>
+          <a:p>
+            <a:pPr algn="ctr" indent="0" marL="0">
+              <a:buNone/>
+            </a:pPr>
+            <a:r>
+              <a:rPr lang="en-US" sz="1600" dirty="0">
+                <a:solidFill>
+                  <a:srgbClr val="78828E"/>
+                </a:solidFill>
+                <a:latin typeface="맑은 고딕" pitchFamily="34" charset="0"/>
+                <a:ea typeface="맑은 고딕" pitchFamily="34" charset="-122"/>
+                <a:cs typeface="맑은 고딕" pitchFamily="34" charset="-120"/>
+              </a:rPr>
+              <a:t>스스로 판단하고 실행</a:t>
+            </a:r>
+            <a:endParaRPr lang="en-US" sz="1600" dirty="0"/>
+          </a:p>
+        </p:txBody>
+      </p:sp>
+      <p:sp>
+        <p:nvSpPr>
+          <p:cNvPr id="8" name="Text 6"/>
+          <p:cNvSpPr/>
+          <p:nvPr/>
+        </p:nvSpPr>
+        <p:spPr>
+          <a:xfrm>
+            <a:off x="3795256" y="2845827"/>
+            <a:ext cx="535021" cy="492220"/>
+          </a:xfrm>
+          <a:prstGeom prst="rect">
+            <a:avLst/>
+          </a:prstGeom>
+          <a:noFill/>
+          <a:ln/>
+        </p:spPr>
+        <p:txBody>
+          <a:bodyPr wrap="square" lIns="0" tIns="0" rIns="0" bIns="0" rtlCol="0" anchor="ctr"/>
+          <a:lstStyle/>
+          <a:p>
+            <a:pPr algn="ctr" indent="0" marL="0">
+              <a:buNone/>
+            </a:pPr>
+            <a:r>
+              <a:rPr lang="en-US" sz="3710" b="1" dirty="0">
+                <a:solidFill>
+                  <a:srgbClr val="9AA5B1"/>
+                </a:solidFill>
+                <a:latin typeface="맑은 고딕" pitchFamily="34" charset="0"/>
+                <a:ea typeface="맑은 고딕" pitchFamily="34" charset="-122"/>
+                <a:cs typeface="맑은 고딕" pitchFamily="34" charset="-120"/>
+              </a:rPr>
+              <a:t>+</a:t>
+            </a:r>
+            <a:endParaRPr lang="en-US" sz="3710" dirty="0"/>
+          </a:p>
+        </p:txBody>
+      </p:sp>
+      <p:sp>
+        <p:nvSpPr>
+          <p:cNvPr id="9" name="Shape 7"/>
+          <p:cNvSpPr/>
+          <p:nvPr/>
+        </p:nvSpPr>
+        <p:spPr>
+          <a:xfrm>
+            <a:off x="4276775" y="2407109"/>
+            <a:ext cx="2461098" cy="2193587"/>
+          </a:xfrm>
+          <a:prstGeom prst="roundRect">
+            <a:avLst>
+              <a:gd name="adj" fmla="val 2501"/>
+            </a:avLst>
+          </a:prstGeom>
+          <a:solidFill>
+            <a:srgbClr val="F4F6F9"/>
+          </a:solidFill>
+          <a:ln w="13970">
+            <a:solidFill>
+              <a:srgbClr val="D6DBE1"/>
+            </a:solidFill>
+            <a:prstDash val="solid"/>
+          </a:ln>
+        </p:spPr>
+      </p:sp>
+      <p:sp>
+        <p:nvSpPr>
+          <p:cNvPr id="10" name="Shape 8"/>
+          <p:cNvSpPr/>
+          <p:nvPr/>
+        </p:nvSpPr>
+        <p:spPr>
+          <a:xfrm>
+            <a:off x="5111408" y="2621118"/>
+            <a:ext cx="791831" cy="1027241"/>
+          </a:xfrm>
+          <a:prstGeom prst="roundRect">
+            <a:avLst>
+              <a:gd name="adj" fmla="val 16167"/>
+            </a:avLst>
+          </a:prstGeom>
+          <a:solidFill>
+            <a:srgbClr val="FFFFFF"/>
+          </a:solidFill>
+          <a:ln w="21590">
+            <a:solidFill>
+              <a:srgbClr val="2E3B4E"/>
+            </a:solidFill>
+            <a:prstDash val="solid"/>
+          </a:ln>
+        </p:spPr>
+      </p:sp>
+      <p:sp>
+        <p:nvSpPr>
+          <p:cNvPr id="11" name="Shape 9"/>
+          <p:cNvSpPr/>
+          <p:nvPr/>
+        </p:nvSpPr>
+        <p:spPr>
+          <a:xfrm>
+            <a:off x="5346818" y="2728122"/>
+            <a:ext cx="321013" cy="32101"/>
+          </a:xfrm>
+          <a:prstGeom prst="rect">
+            <a:avLst/>
+          </a:prstGeom>
+          <a:solidFill>
+            <a:srgbClr val="2E3B4E"/>
+          </a:solidFill>
+          <a:ln w="12700">
+            <a:solidFill>
+              <a:srgbClr val="2E3B4E"/>
+            </a:solidFill>
+            <a:prstDash val="solid"/>
+          </a:ln>
+        </p:spPr>
+      </p:sp>
+      <p:sp>
+        <p:nvSpPr>
+          <p:cNvPr id="12" name="Shape 10"/>
+          <p:cNvSpPr/>
+          <p:nvPr/>
+        </p:nvSpPr>
+        <p:spPr>
+          <a:xfrm>
+            <a:off x="5250514" y="2942131"/>
+            <a:ext cx="513620" cy="385215"/>
+          </a:xfrm>
+          <a:prstGeom prst="roundRect">
+            <a:avLst>
+              <a:gd name="adj" fmla="val 33232"/>
+            </a:avLst>
+          </a:prstGeom>
+          <a:solidFill>
+            <a:srgbClr val="3A6096"/>
+          </a:solidFill>
+          <a:ln w="12700">
+            <a:solidFill>
+              <a:srgbClr val="3A6096"/>
+            </a:solidFill>
+            <a:prstDash val="solid"/>
+          </a:ln>
+        </p:spPr>
+      </p:sp>
+      <p:sp>
+        <p:nvSpPr>
+          <p:cNvPr id="13" name="Text 11"/>
+          <p:cNvSpPr/>
+          <p:nvPr/>
+        </p:nvSpPr>
+        <p:spPr>
+          <a:xfrm>
+            <a:off x="5250514" y="2942131"/>
+            <a:ext cx="513620" cy="385215"/>
+          </a:xfrm>
+          <a:prstGeom prst="rect">
+            <a:avLst/>
+          </a:prstGeom>
+          <a:noFill/>
+          <a:ln/>
+        </p:spPr>
+        <p:txBody>
+          <a:bodyPr wrap="none" lIns="0" tIns="0" rIns="0" bIns="0" rtlCol="0" anchor="ctr"/>
+          <a:lstStyle/>
+          <a:p>
+            <a:pPr algn="ctr" indent="0" marL="0">
+              <a:buNone/>
+            </a:pPr>
+            <a:r>
+              <a:rPr lang="en-US" sz="1430" b="1" dirty="0">
+                <a:solidFill>
+                  <a:srgbClr val="FFFFFF"/>
+                </a:solidFill>
+                <a:latin typeface="맑은 고딕" pitchFamily="34" charset="0"/>
+                <a:ea typeface="맑은 고딕" pitchFamily="34" charset="-122"/>
+                <a:cs typeface="맑은 고딕" pitchFamily="34" charset="-120"/>
+              </a:rPr>
+              <a:t>LLM</a:t>
+            </a:r>
+            <a:endParaRPr lang="en-US" sz="1430" dirty="0"/>
+          </a:p>
+        </p:txBody>
+      </p:sp>
+      <p:sp>
+        <p:nvSpPr>
+          <p:cNvPr id="14" name="Text 12"/>
+          <p:cNvSpPr/>
+          <p:nvPr/>
+        </p:nvSpPr>
+        <p:spPr>
+          <a:xfrm>
+            <a:off x="4276775" y="3776764"/>
+            <a:ext cx="2461098" cy="342414"/>
+          </a:xfrm>
+          <a:prstGeom prst="rect">
+            <a:avLst/>
+          </a:prstGeom>
+          <a:noFill/>
+          <a:ln/>
+        </p:spPr>
+        <p:txBody>
+          <a:bodyPr wrap="square" lIns="0" tIns="0" rIns="0" bIns="0" rtlCol="0" anchor="ctr"/>
+          <a:lstStyle/>
+          <a:p>
+            <a:pPr algn="ctr" indent="0" marL="0">
+              <a:buNone/>
+            </a:pPr>
+            <a:r>
+              <a:rPr lang="en-US" sz="2190" b="1" dirty="0">
+                <a:solidFill>
+                  <a:srgbClr val="2E3B4E"/>
+                </a:solidFill>
+                <a:latin typeface="맑은 고딕" pitchFamily="34" charset="0"/>
+                <a:ea typeface="맑은 고딕" pitchFamily="34" charset="-122"/>
+                <a:cs typeface="맑은 고딕" pitchFamily="34" charset="-120"/>
+              </a:rPr>
+              <a:t>온디바이스 LLM</a:t>
+            </a:r>
+            <a:endParaRPr lang="en-US" sz="2190" dirty="0"/>
+          </a:p>
+        </p:txBody>
+      </p:sp>
+      <p:sp>
+        <p:nvSpPr>
+          <p:cNvPr id="15" name="Text 13"/>
+          <p:cNvSpPr/>
+          <p:nvPr/>
+        </p:nvSpPr>
+        <p:spPr>
+          <a:xfrm>
+            <a:off x="4276775" y="4129878"/>
+            <a:ext cx="2461098" cy="299612"/>
+          </a:xfrm>
+          <a:prstGeom prst="rect">
+            <a:avLst/>
+          </a:prstGeom>
+          <a:noFill/>
+          <a:ln/>
+        </p:spPr>
+        <p:txBody>
+          <a:bodyPr wrap="square" lIns="0" tIns="0" rIns="0" bIns="0" rtlCol="0" anchor="ctr"/>
+          <a:lstStyle/>
+          <a:p>
+            <a:pPr algn="ctr" indent="0" marL="0">
+              <a:buNone/>
+            </a:pPr>
+            <a:r>
+              <a:rPr lang="en-US" sz="1600" dirty="0">
+                <a:solidFill>
+                  <a:srgbClr val="78828E"/>
+                </a:solidFill>
+                <a:latin typeface="맑은 고딕" pitchFamily="34" charset="0"/>
+                <a:ea typeface="맑은 고딕" pitchFamily="34" charset="-122"/>
+                <a:cs typeface="맑은 고딕" pitchFamily="34" charset="-120"/>
+              </a:rPr>
+              <a:t>기기 안에서 추론</a:t>
+            </a:r>
+            <a:endParaRPr lang="en-US" sz="1600" dirty="0"/>
+          </a:p>
+        </p:txBody>
+      </p:sp>
+      <p:sp>
+        <p:nvSpPr>
+          <p:cNvPr id="16" name="Shape 14"/>
+          <p:cNvSpPr/>
+          <p:nvPr/>
+        </p:nvSpPr>
+        <p:spPr>
+          <a:xfrm>
+            <a:off x="6898380" y="3113337"/>
+            <a:ext cx="674127" cy="0"/>
+          </a:xfrm>
+          <a:prstGeom prst="line">
+            <a:avLst/>
+          </a:prstGeom>
+          <a:noFill/>
+          <a:ln w="27940">
+            <a:solidFill>
+              <a:srgbClr val="9AA5B1"/>
+            </a:solidFill>
+            <a:prstDash val="solid"/>
+            <a:tailEnd type="triangle"/>
+          </a:ln>
+        </p:spPr>
+      </p:sp>
+      <p:sp>
+        <p:nvSpPr>
+          <p:cNvPr id="17" name="Shape 15"/>
+          <p:cNvSpPr/>
+          <p:nvPr/>
+        </p:nvSpPr>
+        <p:spPr>
+          <a:xfrm>
+            <a:off x="7700911" y="2407109"/>
+            <a:ext cx="3103123" cy="2193587"/>
+          </a:xfrm>
+          <a:prstGeom prst="roundRect">
+            <a:avLst>
+              <a:gd name="adj" fmla="val 2501"/>
+            </a:avLst>
+          </a:prstGeom>
+          <a:solidFill>
+            <a:srgbClr val="FFFFFF"/>
+          </a:solidFill>
+          <a:ln w="20320">
+            <a:solidFill>
+              <a:srgbClr val="6C93C9"/>
+            </a:solidFill>
+            <a:prstDash val="solid"/>
+          </a:ln>
+        </p:spPr>
+      </p:sp>
+      <p:sp>
+        <p:nvSpPr>
+          <p:cNvPr id="18" name="Shape 16"/>
+          <p:cNvSpPr/>
+          <p:nvPr/>
+        </p:nvSpPr>
+        <p:spPr>
+          <a:xfrm>
+            <a:off x="8300135" y="2663920"/>
+            <a:ext cx="577823" cy="898836"/>
+          </a:xfrm>
+          <a:prstGeom prst="roundRect">
+            <a:avLst>
+              <a:gd name="adj" fmla="val 22155"/>
+            </a:avLst>
+          </a:prstGeom>
+          <a:solidFill>
+            <a:srgbClr val="EBF1F9"/>
+          </a:solidFill>
+          <a:ln w="21590">
+            <a:solidFill>
+              <a:srgbClr val="3A6096"/>
+            </a:solidFill>
+            <a:prstDash val="solid"/>
+          </a:ln>
+        </p:spPr>
+      </p:sp>
+      <p:sp>
+        <p:nvSpPr>
+          <p:cNvPr id="19" name="Shape 17"/>
+          <p:cNvSpPr/>
+          <p:nvPr/>
+        </p:nvSpPr>
+        <p:spPr>
+          <a:xfrm>
+            <a:off x="8428540" y="2770924"/>
+            <a:ext cx="321013" cy="32101"/>
+          </a:xfrm>
+          <a:prstGeom prst="rect">
+            <a:avLst/>
+          </a:prstGeom>
+          <a:solidFill>
+            <a:srgbClr val="3A6096"/>
+          </a:solidFill>
+          <a:ln w="12700">
+            <a:solidFill>
+              <a:srgbClr val="3A6096"/>
+            </a:solidFill>
+            <a:prstDash val="solid"/>
+          </a:ln>
+        </p:spPr>
+      </p:sp>
+      <p:sp>
+        <p:nvSpPr>
+          <p:cNvPr id="20" name="Shape 18"/>
+          <p:cNvSpPr/>
+          <p:nvPr/>
+        </p:nvSpPr>
+        <p:spPr>
+          <a:xfrm>
+            <a:off x="8407140" y="2984932"/>
+            <a:ext cx="363814" cy="256810"/>
+          </a:xfrm>
+          <a:prstGeom prst="roundRect">
+            <a:avLst>
+              <a:gd name="adj" fmla="val 49849"/>
+            </a:avLst>
+          </a:prstGeom>
+          <a:solidFill>
+            <a:srgbClr val="3A6096"/>
+          </a:solidFill>
+          <a:ln w="12700">
+            <a:solidFill>
+              <a:srgbClr val="3A6096"/>
+            </a:solidFill>
+            <a:prstDash val="solid"/>
+          </a:ln>
+        </p:spPr>
+      </p:sp>
+      <p:sp>
+        <p:nvSpPr>
+          <p:cNvPr id="21" name="Shape 19"/>
+          <p:cNvSpPr/>
+          <p:nvPr/>
+        </p:nvSpPr>
+        <p:spPr>
+          <a:xfrm>
+            <a:off x="9626988" y="2663920"/>
+            <a:ext cx="577823" cy="898836"/>
+          </a:xfrm>
+          <a:prstGeom prst="roundRect">
+            <a:avLst>
+              <a:gd name="adj" fmla="val 22155"/>
+            </a:avLst>
+          </a:prstGeom>
+          <a:solidFill>
+            <a:srgbClr val="EBF1F9"/>
+          </a:solidFill>
+          <a:ln w="21590">
+            <a:solidFill>
+              <a:srgbClr val="3A6096"/>
+            </a:solidFill>
+            <a:prstDash val="solid"/>
+          </a:ln>
+        </p:spPr>
+      </p:sp>
+      <p:sp>
+        <p:nvSpPr>
+          <p:cNvPr id="22" name="Shape 20"/>
+          <p:cNvSpPr/>
+          <p:nvPr/>
+        </p:nvSpPr>
+        <p:spPr>
+          <a:xfrm>
+            <a:off x="9755393" y="2770924"/>
+            <a:ext cx="321013" cy="32101"/>
+          </a:xfrm>
+          <a:prstGeom prst="rect">
+            <a:avLst/>
+          </a:prstGeom>
+          <a:solidFill>
+            <a:srgbClr val="3A6096"/>
+          </a:solidFill>
+          <a:ln w="12700">
+            <a:solidFill>
+              <a:srgbClr val="3A6096"/>
+            </a:solidFill>
+            <a:prstDash val="solid"/>
+          </a:ln>
+        </p:spPr>
+      </p:sp>
+      <p:sp>
+        <p:nvSpPr>
+          <p:cNvPr id="23" name="Shape 21"/>
+          <p:cNvSpPr/>
+          <p:nvPr/>
+        </p:nvSpPr>
+        <p:spPr>
+          <a:xfrm>
+            <a:off x="9733992" y="2984932"/>
+            <a:ext cx="363814" cy="256810"/>
+          </a:xfrm>
+          <a:prstGeom prst="roundRect">
+            <a:avLst>
+              <a:gd name="adj" fmla="val 49849"/>
+            </a:avLst>
+          </a:prstGeom>
+          <a:solidFill>
+            <a:srgbClr val="3A6096"/>
+          </a:solidFill>
+          <a:ln w="12700">
+            <a:solidFill>
+              <a:srgbClr val="3A6096"/>
+            </a:solidFill>
+            <a:prstDash val="solid"/>
+          </a:ln>
+        </p:spPr>
+      </p:sp>
+      <p:sp>
+        <p:nvSpPr>
+          <p:cNvPr id="24" name="Shape 22"/>
+          <p:cNvSpPr/>
+          <p:nvPr/>
+        </p:nvSpPr>
+        <p:spPr>
+          <a:xfrm>
+            <a:off x="8942161" y="3113337"/>
+            <a:ext cx="620625" cy="0"/>
+          </a:xfrm>
+          <a:prstGeom prst="line">
+            <a:avLst/>
+          </a:prstGeom>
+          <a:noFill/>
+          <a:ln w="27940">
+            <a:solidFill>
+              <a:srgbClr val="3A6096"/>
+            </a:solidFill>
+            <a:prstDash val="solid"/>
+            <a:headEnd type="triangle"/>
+            <a:tailEnd type="triangle"/>
+          </a:ln>
+        </p:spPr>
+      </p:sp>
+      <p:sp>
+        <p:nvSpPr>
+          <p:cNvPr id="25" name="Text 23"/>
+          <p:cNvSpPr/>
+          <p:nvPr/>
+        </p:nvSpPr>
+        <p:spPr>
+          <a:xfrm>
+            <a:off x="7700911" y="3776764"/>
+            <a:ext cx="3103123" cy="342414"/>
+          </a:xfrm>
+          <a:prstGeom prst="rect">
+            <a:avLst/>
+          </a:prstGeom>
+          <a:noFill/>
+          <a:ln/>
+        </p:spPr>
+        <p:txBody>
+          <a:bodyPr wrap="square" lIns="0" tIns="0" rIns="0" bIns="0" rtlCol="0" anchor="ctr"/>
+          <a:lstStyle/>
+          <a:p>
+            <a:pPr algn="ctr" indent="0" marL="0">
+              <a:buNone/>
+            </a:pPr>
+            <a:r>
+              <a:rPr lang="en-US" sz="2190" b="1" dirty="0">
+                <a:solidFill>
+                  <a:srgbClr val="3A6096"/>
+                </a:solidFill>
+                <a:latin typeface="맑은 고딕" pitchFamily="34" charset="0"/>
+                <a:ea typeface="맑은 고딕" pitchFamily="34" charset="-122"/>
+                <a:cs typeface="맑은 고딕" pitchFamily="34" charset="-120"/>
+              </a:rPr>
+              <a:t>단말 내 자율 협상</a:t>
+            </a:r>
+            <a:endParaRPr lang="en-US" sz="2190" dirty="0"/>
+          </a:p>
+        </p:txBody>
+      </p:sp>
+      <p:sp>
+        <p:nvSpPr>
+          <p:cNvPr id="26" name="Text 24"/>
+          <p:cNvSpPr/>
+          <p:nvPr/>
+        </p:nvSpPr>
+        <p:spPr>
+          <a:xfrm>
+            <a:off x="7700911" y="4129878"/>
+            <a:ext cx="3103123" cy="299612"/>
+          </a:xfrm>
+          <a:prstGeom prst="rect">
+            <a:avLst/>
+          </a:prstGeom>
+          <a:noFill/>
+          <a:ln/>
+        </p:spPr>
+        <p:txBody>
+          <a:bodyPr wrap="square" lIns="0" tIns="0" rIns="0" bIns="0" rtlCol="0" anchor="ctr"/>
+          <a:lstStyle/>
+          <a:p>
+            <a:pPr algn="ctr" indent="0" marL="0">
+              <a:buNone/>
+            </a:pPr>
+            <a:r>
+              <a:rPr lang="en-US" sz="1600" dirty="0">
+                <a:solidFill>
+                  <a:srgbClr val="78828E"/>
+                </a:solidFill>
+                <a:latin typeface="맑은 고딕" pitchFamily="34" charset="0"/>
+                <a:ea typeface="맑은 고딕" pitchFamily="34" charset="-122"/>
+                <a:cs typeface="맑은 고딕" pitchFamily="34" charset="-120"/>
+              </a:rPr>
+              <a:t>데이터는 밖으로 나가지 않음</a:t>
+            </a:r>
+            <a:endParaRPr lang="en-US" sz="1600" dirty="0"/>
+          </a:p>
+        </p:txBody>
+      </p:sp>
+      <p:sp>
+        <p:nvSpPr>
+          <p:cNvPr id="27" name="Text 25"/>
+          <p:cNvSpPr/>
+          <p:nvPr/>
+        </p:nvSpPr>
+        <p:spPr>
+          <a:xfrm>
+            <a:off x="1066648" y="4953811"/>
+            <a:ext cx="10058400" cy="321013"/>
+          </a:xfrm>
+          <a:prstGeom prst="rect">
+            <a:avLst/>
+          </a:prstGeom>
+          <a:noFill/>
+          <a:ln/>
+        </p:spPr>
+        <p:txBody>
+          <a:bodyPr wrap="square" lIns="0" tIns="0" rIns="0" bIns="0" rtlCol="0" anchor="ctr"/>
+          <a:lstStyle/>
+          <a:p>
+            <a:pPr algn="ctr" indent="0" marL="0">
+              <a:buNone/>
+            </a:pPr>
+            <a:r>
+              <a:rPr lang="en-US" sz="1770" dirty="0">
+                <a:solidFill>
+                  <a:srgbClr val="78828E"/>
+                </a:solidFill>
+                <a:latin typeface="맑은 고딕" pitchFamily="34" charset="0"/>
+                <a:ea typeface="맑은 고딕" pitchFamily="34" charset="-122"/>
+                <a:cs typeface="맑은 고딕" pitchFamily="34" charset="-120"/>
+              </a:rPr>
+              <a:t>두 기술이 함께 성숙하면서, 협상 추론을 기기 안에서 처리할 수 있게 됨</a:t>
+            </a:r>
+            <a:endParaRPr lang="en-US" sz="1770" dirty="0"/>
           </a:p>
         </p:txBody>
       </p:sp>

</xml_diff>